<commit_message>
Keep outreach intelligence private and neutralize research titles
</commit_message>
<xml_diff>
--- a/presentacion/Motor_Pampa_Research_2026-09-23.pptx
+++ b/presentacion/Motor_Pampa_Research_2026-09-23.pptx
@@ -2,23 +2,23 @@
 <file path=ppt/presentation.xml><?xml version="1.0" encoding="utf-8"?>
 <p:presentation xmlns:p="http://schemas.openxmlformats.org/presentationml/2006/main">
   <p:sldMasterIdLst>
-    <p:sldMasterId xmlns:r="http://schemas.openxmlformats.org/officeDocument/2006/relationships" id="2147483648" r:id="R94882bd457ea4268"/>
+    <p:sldMasterId xmlns:r="http://schemas.openxmlformats.org/officeDocument/2006/relationships" id="2147483648" r:id="R93fabd25a9d74f20"/>
   </p:sldMasterIdLst>
   <p:notesMasterIdLst>
-    <p:notesMasterId xmlns:r="http://schemas.openxmlformats.org/officeDocument/2006/relationships" r:id="Rcf24cf950dcf4d85"/>
+    <p:notesMasterId xmlns:r="http://schemas.openxmlformats.org/officeDocument/2006/relationships" r:id="R956a9163603d4731"/>
   </p:notesMasterIdLst>
   <p:sldIdLst>
-    <p:sldId xmlns:r="http://schemas.openxmlformats.org/officeDocument/2006/relationships" id="256" r:id="R6e70670106684abe"/>
-    <p:sldId xmlns:r="http://schemas.openxmlformats.org/officeDocument/2006/relationships" id="257" r:id="R445000ea4cae4f96"/>
-    <p:sldId xmlns:r="http://schemas.openxmlformats.org/officeDocument/2006/relationships" id="258" r:id="R71ab105677724ad3"/>
-    <p:sldId xmlns:r="http://schemas.openxmlformats.org/officeDocument/2006/relationships" id="259" r:id="R8221bca7aecc4a02"/>
-    <p:sldId xmlns:r="http://schemas.openxmlformats.org/officeDocument/2006/relationships" id="260" r:id="R2a306eb2effa4691"/>
-    <p:sldId xmlns:r="http://schemas.openxmlformats.org/officeDocument/2006/relationships" id="261" r:id="Ref5ccf0d05d64f99"/>
-    <p:sldId xmlns:r="http://schemas.openxmlformats.org/officeDocument/2006/relationships" id="262" r:id="R12d308d456ed4910"/>
-    <p:sldId xmlns:r="http://schemas.openxmlformats.org/officeDocument/2006/relationships" id="263" r:id="Rae4a8c0eccea4aca"/>
-    <p:sldId xmlns:r="http://schemas.openxmlformats.org/officeDocument/2006/relationships" id="264" r:id="R70736adcd7524e24"/>
-    <p:sldId xmlns:r="http://schemas.openxmlformats.org/officeDocument/2006/relationships" id="265" r:id="R5d1f14f0f1864b72"/>
-    <p:sldId xmlns:r="http://schemas.openxmlformats.org/officeDocument/2006/relationships" id="266" r:id="R02f97e26cf534c35"/>
+    <p:sldId xmlns:r="http://schemas.openxmlformats.org/officeDocument/2006/relationships" id="256" r:id="R2c3e899461b141cc"/>
+    <p:sldId xmlns:r="http://schemas.openxmlformats.org/officeDocument/2006/relationships" id="257" r:id="Raacea5e55cd24364"/>
+    <p:sldId xmlns:r="http://schemas.openxmlformats.org/officeDocument/2006/relationships" id="258" r:id="Ra89717ca6d874b5c"/>
+    <p:sldId xmlns:r="http://schemas.openxmlformats.org/officeDocument/2006/relationships" id="259" r:id="R773bf9ccdd094ce1"/>
+    <p:sldId xmlns:r="http://schemas.openxmlformats.org/officeDocument/2006/relationships" id="260" r:id="R4aaf0004251d4675"/>
+    <p:sldId xmlns:r="http://schemas.openxmlformats.org/officeDocument/2006/relationships" id="261" r:id="R8fbf9ded7b204d8d"/>
+    <p:sldId xmlns:r="http://schemas.openxmlformats.org/officeDocument/2006/relationships" id="262" r:id="R04ebcc1eb4324016"/>
+    <p:sldId xmlns:r="http://schemas.openxmlformats.org/officeDocument/2006/relationships" id="263" r:id="R50507d88cc8b416a"/>
+    <p:sldId xmlns:r="http://schemas.openxmlformats.org/officeDocument/2006/relationships" id="264" r:id="R4bcdff7ba76f4c97"/>
+    <p:sldId xmlns:r="http://schemas.openxmlformats.org/officeDocument/2006/relationships" id="265" r:id="R2cc97e88c9a24809"/>
+    <p:sldId xmlns:r="http://schemas.openxmlformats.org/officeDocument/2006/relationships" id="266" r:id="R1b9bbd2583fb4a37"/>
   </p:sldIdLst>
   <p:sldSz cx="12192000" cy="6858000"/>
   <p:notesSz cx="6858000" cy="9144000"/>
@@ -1245,7 +1245,7 @@
   </p:cSld>
   <p:clrMap bg1="lt1" tx1="dk1" bg2="lt2" tx2="dk2" accent1="accent1" accent2="accent2" accent3="accent3" accent4="accent4" accent5="accent5" accent6="accent6" hlink="hlink" folHlink="folHlink"/>
   <p:sldLayoutIdLst>
-    <p:sldLayoutId xmlns:r="http://schemas.openxmlformats.org/officeDocument/2006/relationships" id="2147483649" r:id="R1090696cbd814281"/>
+    <p:sldLayoutId xmlns:r="http://schemas.openxmlformats.org/officeDocument/2006/relationships" id="2147483649" r:id="Rf466601c65af40b7"/>
   </p:sldLayoutIdLst>
   <p:txStyles>
     <p:titleStyle>
@@ -11253,7 +11253,7 @@
                 <a:ea typeface="Arial"/>
                 <a:cs typeface="Arial"/>
               </a:rPr>
-              <a:t>OBSERVATORIO CANNIS: AUDITORÍA DEL DOSSIER</a:t>
+              <a:t>OBSERVATORIO SECTORIAL: AUDITORÍA DEL DOSSIER</a:t>
             </a:r>
           </a:p>
         </p:txBody>
@@ -13563,6 +13563,7 @@
           <a:lstStyle xmlns:a="http://schemas.openxmlformats.org/drawingml/2006/main"/>
           <a:p xmlns:a="http://schemas.openxmlformats.org/drawingml/2006/main">
             <a:pPr>
+              <a:buNone/>
               <a:defRPr sz="1275" b="1">
                 <a:solidFill>
                   <a:srgbClr val="B8342B"/>

</xml_diff>